<commit_message>
added error bars to supp fig s2
</commit_message>
<xml_diff>
--- a/results/figures/figureS2.pptx
+++ b/results/figures/figureS2.pptx
@@ -104,7 +104,49 @@
       </a:defRPr>
     </a:lvl9pPr>
   </p:defaultTextStyle>
+  <p:extLst>
+    <p:ext uri="{EFAFB233-063F-42B5-8137-9DF3F51BA10A}">
+      <p15:sldGuideLst xmlns:p15="http://schemas.microsoft.com/office/powerpoint/2012/main"/>
+    </p:ext>
+  </p:extLst>
 </p:presentation>
+</file>
+
+<file path=ppt/changesInfos/changesInfo1.xml><?xml version="1.0" encoding="utf-8"?>
+<pc:chgInfo xmlns:a="http://schemas.openxmlformats.org/drawingml/2006/main" xmlns:r="http://schemas.openxmlformats.org/officeDocument/2006/relationships" xmlns:ac="http://schemas.microsoft.com/office/drawing/2013/main/command" xmlns:pc="http://schemas.microsoft.com/office/powerpoint/2013/main/command">
+  <pc:docChgLst>
+    <pc:chgData name="Shevlin, Blair" userId="84ba045b-a58b-4124-82eb-e2fd3a9b1d68" providerId="ADAL" clId="{30024126-5384-4DA1-8B4F-6CA6F8B40A7D}"/>
+    <pc:docChg chg="custSel modSld">
+      <pc:chgData name="Shevlin, Blair" userId="84ba045b-a58b-4124-82eb-e2fd3a9b1d68" providerId="ADAL" clId="{30024126-5384-4DA1-8B4F-6CA6F8B40A7D}" dt="2026-08-24T14:29:15.167" v="3" actId="1076"/>
+      <pc:docMkLst>
+        <pc:docMk/>
+      </pc:docMkLst>
+      <pc:sldChg chg="addSp delSp modSp mod">
+        <pc:chgData name="Shevlin, Blair" userId="84ba045b-a58b-4124-82eb-e2fd3a9b1d68" providerId="ADAL" clId="{30024126-5384-4DA1-8B4F-6CA6F8B40A7D}" dt="2026-08-24T14:29:15.167" v="3" actId="1076"/>
+        <pc:sldMkLst>
+          <pc:docMk/>
+          <pc:sldMk cId="2940960004" sldId="257"/>
+        </pc:sldMkLst>
+        <pc:picChg chg="del">
+          <ac:chgData name="Shevlin, Blair" userId="84ba045b-a58b-4124-82eb-e2fd3a9b1d68" providerId="ADAL" clId="{30024126-5384-4DA1-8B4F-6CA6F8B40A7D}" dt="2026-08-24T14:28:41.545" v="0" actId="478"/>
+          <ac:picMkLst>
+            <pc:docMk/>
+            <pc:sldMk cId="2940960004" sldId="257"/>
+            <ac:picMk id="3" creationId="{8EC14799-A078-1728-8D30-F0C6E70A8D6F}"/>
+          </ac:picMkLst>
+        </pc:picChg>
+        <pc:picChg chg="add mod ord">
+          <ac:chgData name="Shevlin, Blair" userId="84ba045b-a58b-4124-82eb-e2fd3a9b1d68" providerId="ADAL" clId="{30024126-5384-4DA1-8B4F-6CA6F8B40A7D}" dt="2026-08-24T14:29:15.167" v="3" actId="1076"/>
+          <ac:picMkLst>
+            <pc:docMk/>
+            <pc:sldMk cId="2940960004" sldId="257"/>
+            <ac:picMk id="4" creationId="{B879DA94-11EF-687B-98F0-43ADE7DEFA53}"/>
+          </ac:picMkLst>
+        </pc:picChg>
+      </pc:sldChg>
+    </pc:docChg>
+  </pc:docChgLst>
+</pc:chgInfo>
 </file>
 
 <file path=ppt/slideLayouts/slideLayout1.xml><?xml version="1.0" encoding="utf-8"?>
@@ -254,7 +296,7 @@
           <a:p>
             <a:fld id="{FF27B50F-E66E-4C48-B3A8-26C19A85A333}" type="datetimeFigureOut">
               <a:rPr lang="en-US" smtClean="0"/>
-              <a:t>3/13/2025</a:t>
+              <a:t>8/24/2026</a:t>
             </a:fld>
             <a:endParaRPr lang="en-US"/>
           </a:p>
@@ -452,7 +494,7 @@
           <a:p>
             <a:fld id="{FF27B50F-E66E-4C48-B3A8-26C19A85A333}" type="datetimeFigureOut">
               <a:rPr lang="en-US" smtClean="0"/>
-              <a:t>3/13/2025</a:t>
+              <a:t>8/24/2026</a:t>
             </a:fld>
             <a:endParaRPr lang="en-US"/>
           </a:p>
@@ -660,7 +702,7 @@
           <a:p>
             <a:fld id="{FF27B50F-E66E-4C48-B3A8-26C19A85A333}" type="datetimeFigureOut">
               <a:rPr lang="en-US" smtClean="0"/>
-              <a:t>3/13/2025</a:t>
+              <a:t>8/24/2026</a:t>
             </a:fld>
             <a:endParaRPr lang="en-US"/>
           </a:p>
@@ -858,7 +900,7 @@
           <a:p>
             <a:fld id="{FF27B50F-E66E-4C48-B3A8-26C19A85A333}" type="datetimeFigureOut">
               <a:rPr lang="en-US" smtClean="0"/>
-              <a:t>3/13/2025</a:t>
+              <a:t>8/24/2026</a:t>
             </a:fld>
             <a:endParaRPr lang="en-US"/>
           </a:p>
@@ -1133,7 +1175,7 @@
           <a:p>
             <a:fld id="{FF27B50F-E66E-4C48-B3A8-26C19A85A333}" type="datetimeFigureOut">
               <a:rPr lang="en-US" smtClean="0"/>
-              <a:t>3/13/2025</a:t>
+              <a:t>8/24/2026</a:t>
             </a:fld>
             <a:endParaRPr lang="en-US"/>
           </a:p>
@@ -1398,7 +1440,7 @@
           <a:p>
             <a:fld id="{FF27B50F-E66E-4C48-B3A8-26C19A85A333}" type="datetimeFigureOut">
               <a:rPr lang="en-US" smtClean="0"/>
-              <a:t>3/13/2025</a:t>
+              <a:t>8/24/2026</a:t>
             </a:fld>
             <a:endParaRPr lang="en-US"/>
           </a:p>
@@ -1810,7 +1852,7 @@
           <a:p>
             <a:fld id="{FF27B50F-E66E-4C48-B3A8-26C19A85A333}" type="datetimeFigureOut">
               <a:rPr lang="en-US" smtClean="0"/>
-              <a:t>3/13/2025</a:t>
+              <a:t>8/24/2026</a:t>
             </a:fld>
             <a:endParaRPr lang="en-US"/>
           </a:p>
@@ -1951,7 +1993,7 @@
           <a:p>
             <a:fld id="{FF27B50F-E66E-4C48-B3A8-26C19A85A333}" type="datetimeFigureOut">
               <a:rPr lang="en-US" smtClean="0"/>
-              <a:t>3/13/2025</a:t>
+              <a:t>8/24/2026</a:t>
             </a:fld>
             <a:endParaRPr lang="en-US"/>
           </a:p>
@@ -2064,7 +2106,7 @@
           <a:p>
             <a:fld id="{FF27B50F-E66E-4C48-B3A8-26C19A85A333}" type="datetimeFigureOut">
               <a:rPr lang="en-US" smtClean="0"/>
-              <a:t>3/13/2025</a:t>
+              <a:t>8/24/2026</a:t>
             </a:fld>
             <a:endParaRPr lang="en-US"/>
           </a:p>
@@ -2375,7 +2417,7 @@
           <a:p>
             <a:fld id="{FF27B50F-E66E-4C48-B3A8-26C19A85A333}" type="datetimeFigureOut">
               <a:rPr lang="en-US" smtClean="0"/>
-              <a:t>3/13/2025</a:t>
+              <a:t>8/24/2026</a:t>
             </a:fld>
             <a:endParaRPr lang="en-US"/>
           </a:p>
@@ -2663,7 +2705,7 @@
           <a:p>
             <a:fld id="{FF27B50F-E66E-4C48-B3A8-26C19A85A333}" type="datetimeFigureOut">
               <a:rPr lang="en-US" smtClean="0"/>
-              <a:t>3/13/2025</a:t>
+              <a:t>8/24/2026</a:t>
             </a:fld>
             <a:endParaRPr lang="en-US"/>
           </a:p>
@@ -2904,7 +2946,7 @@
           <a:p>
             <a:fld id="{FF27B50F-E66E-4C48-B3A8-26C19A85A333}" type="datetimeFigureOut">
               <a:rPr lang="en-US" smtClean="0"/>
-              <a:t>3/13/2025</a:t>
+              <a:t>8/24/2026</a:t>
             </a:fld>
             <a:endParaRPr lang="en-US"/>
           </a:p>
@@ -3329,10 +3371,10 @@
       </p:grpSpPr>
       <p:pic>
         <p:nvPicPr>
-          <p:cNvPr id="3" name="Picture 2" descr="A screenshot of a graph&#10;&#10;AI-generated content may be incorrect.">
-            <a:extLst>
-              <a:ext uri="{FF2B5EF4-FFF2-40B4-BE49-F238E27FC236}">
-                <a16:creationId xmlns:a16="http://schemas.microsoft.com/office/drawing/2014/main" id="{8EC14799-A078-1728-8D30-F0C6E70A8D6F}"/>
+          <p:cNvPr id="4" name="Picture 3">
+            <a:extLst>
+              <a:ext uri="{FF2B5EF4-FFF2-40B4-BE49-F238E27FC236}">
+                <a16:creationId xmlns:a16="http://schemas.microsoft.com/office/drawing/2014/main" id="{B879DA94-11EF-687B-98F0-43ADE7DEFA53}"/>
               </a:ext>
             </a:extLst>
           </p:cNvPr>
@@ -3355,7 +3397,7 @@
         </p:blipFill>
         <p:spPr>
           <a:xfrm>
-            <a:off x="1809750" y="0"/>
+            <a:off x="1895609" y="0"/>
             <a:ext cx="8572500" cy="6858000"/>
           </a:xfrm>
           <a:prstGeom prst="rect">

</xml_diff>